<commit_message>
docs: add the scripts that rebuild the pitch deck
capture.mjs takes the deck's screenshots and check-in recording from a
scratch app; build.mjs writes the deck from them with pptxgenjs. The deck
is rebuilt from the scripts, so its screenshots are a fresh capture of the
same seeded Goals.

Co-Authored-By: Claude Fable 5.1 <noreply@anthropic.com>
Claude-Session: https://claude.ai/code/session_01WRw3yjTmAWhSDiqeY7sSx9
</commit_message>
<xml_diff>
--- a/docs/pitch/goal-tracker-pitch.pptx
+++ b/docs/pitch/goal-tracker-pitch.pptx
@@ -115,14 +115,14 @@
   <p:extLst>
     <p:ext uri="{521415D9-36F7-43E2-AB2F-B90AF26B5E84}">
       <p14:sectionLst xmlns:p14="http://schemas.microsoft.com/office/powerpoint/2010/main">
-        <p14:section name="Pitch" id="{f8a066aa-b228-e0eb-ec13-18b00cc0692e}">
+        <p14:section name="Pitch" id="{453962a9-f110-be8f-a27c-e48c2ee7a611}">
           <p14:sldIdLst>
             <p14:sldId id="256"/>
             <p14:sldId id="257"/>
             <p14:sldId id="258"/>
           </p14:sldIdLst>
         </p14:section>
-        <p14:section name="Product tour" id="{80ea9a69-c646-151d-b5b5-bd4a8c3b9a01}">
+        <p14:section name="Product tour" id="{692e737a-8201-5046-a647-a55b777de4f8}">
           <p14:sldIdLst>
             <p14:sldId id="259"/>
             <p14:sldId id="260"/>
@@ -131,7 +131,7 @@
             <p14:sldId id="263"/>
           </p14:sldIdLst>
         </p14:section>
-        <p14:section name="Ask" id="{84317332-b8b8-1072-5d9c-37bf522cc56c}">
+        <p14:section name="Ask" id="{9eb87cb8-f60e-140e-1e7a-1c3e4cd34762}">
           <p14:sldIdLst>
             <p14:sldId id="264"/>
           </p14:sldIdLst>

</xml_diff>